<commit_message>
Update presentation deck with Technical Documentation slide; remove SRS doc
Folded a Technical Documentation section into the Testing & CI slide
(renamed Testing, CI & Documentation) to cover a required task from
the hiring project brief that the deck was missing, while staying
within the 15-slide cap. Also corrected the stale test count (19 -> 22).
</commit_message>
<xml_diff>
--- a/LSA_Booking_Presentation.pptx
+++ b/LSA_Booking_Presentation.pptx
@@ -4674,7 +4674,7 @@
                 </a:solidFill>
                 <a:latin typeface="Calibri"/>
               </a:rPr>
-              <a:t>Testing &amp; CI</a:t>
+              <a:t>Testing, CI &amp; Documentation</a:t>
             </a:r>
           </a:p>
         </p:txBody>
@@ -4759,7 +4759,7 @@
         </p:nvGraphicFramePr>
         <p:xfrm>
           <a:off x="502920" y="1417320"/>
-          <a:ext cx="11155680" cy="3200400"/>
+          <a:ext cx="11155680" cy="2750000"/>
         </p:xfrm>
         <a:graphic>
           <a:graphicData uri="http://schemas.openxmlformats.org/drawingml/2006/table">
@@ -4771,7 +4771,7 @@
                 <a:gridCol w="3108960"/>
                 <a:gridCol w="8046720"/>
               </a:tblGrid>
-              <a:tr h="640080">
+              <a:tr h="550000">
                 <a:tc>
                   <a:txBody>
                     <a:bodyPr/>
@@ -4819,7 +4819,7 @@
                   </a:tcPr>
                 </a:tc>
               </a:tr>
-              <a:tr h="640080">
+              <a:tr h="550000">
                 <a:tc>
                   <a:txBody>
                     <a:bodyPr/>
@@ -4867,7 +4867,7 @@
                   </a:tcPr>
                 </a:tc>
               </a:tr>
-              <a:tr h="640080">
+              <a:tr h="550000">
                 <a:tc>
                   <a:txBody>
                     <a:bodyPr/>
@@ -4915,7 +4915,7 @@
                   </a:tcPr>
                 </a:tc>
               </a:tr>
-              <a:tr h="640080">
+              <a:tr h="550000">
                 <a:tc>
                   <a:txBody>
                     <a:bodyPr/>
@@ -4963,7 +4963,7 @@
                   </a:tcPr>
                 </a:tc>
               </a:tr>
-              <a:tr h="640080">
+              <a:tr h="550000">
                 <a:tc>
                   <a:txBody>
                     <a:bodyPr/>
@@ -5023,8 +5023,8 @@
         </p:nvSpPr>
         <p:spPr>
           <a:xfrm>
-            <a:off x="502920" y="4846320"/>
-            <a:ext cx="11155680" cy="365760"/>
+            <a:off x="502920" y="4317320"/>
+            <a:ext cx="11155680" cy="320040"/>
           </a:xfrm>
           <a:prstGeom prst="rect">
             <a:avLst/>
@@ -5045,7 +5045,7 @@
                 </a:solidFill>
                 <a:latin typeface="Calibri"/>
               </a:rPr>
-              <a:t>19 tests total · python manage.py test bookings</a:t>
+              <a:t>22 tests total · python manage.py test bookings</a:t>
             </a:r>
           </a:p>
         </p:txBody>
@@ -5058,8 +5058,8 @@
         </p:nvSpPr>
         <p:spPr>
           <a:xfrm>
-            <a:off x="502920" y="5303520"/>
-            <a:ext cx="11155680" cy="1097280"/>
+            <a:off x="502920" y="4737360"/>
+            <a:ext cx="11155680" cy="520000"/>
           </a:xfrm>
           <a:prstGeom prst="rect">
             <a:avLst/>
@@ -5074,17 +5074,91 @@
           <a:p>
             <a:pPr>
               <a:spcAft>
-                <a:spcPts val="800"/>
+                <a:spcPts val="600"/>
               </a:spcAft>
             </a:pPr>
             <a:r>
-              <a:rPr sz="1400">
+              <a:rPr sz="1300">
                 <a:solidFill>
                   <a:srgbClr val="1A1F24"/>
                 </a:solidFill>
                 <a:latin typeface="Calibri"/>
               </a:rPr>
               <a:t>— GitHub Actions runs the full suite against a real MySQL service container on every push — no SQLite substitution anywhere, including CI.</a:t>
+            </a:r>
+          </a:p>
+        </p:txBody>
+      </p:sp>
+      <p:sp>
+        <p:nvSpPr>
+          <p:cNvPr id="12" name="TextBox 11"/>
+          <p:cNvSpPr txBox="1"/>
+          <p:nvPr/>
+        </p:nvSpPr>
+        <p:spPr>
+          <a:xfrm>
+            <a:off x="502920" y="5407360"/>
+            <a:ext cx="11155680" cy="260000"/>
+          </a:xfrm>
+          <a:prstGeom prst="rect">
+            <a:avLst/>
+          </a:prstGeom>
+          <a:noFill/>
+        </p:spPr>
+        <p:txBody>
+          <a:bodyPr wrap="square">
+            <a:spAutoFit/>
+          </a:bodyPr>
+          <a:lstStyle/>
+          <a:p>
+            <a:pPr algn="l"/>
+            <a:r>
+              <a:rPr sz="1400" b="1" i="0">
+                <a:solidFill>
+                  <a:srgbClr val="0F2A43"/>
+                </a:solidFill>
+                <a:latin typeface="Calibri"/>
+              </a:rPr>
+              <a:t>Technical Documentation</a:t>
+            </a:r>
+          </a:p>
+        </p:txBody>
+      </p:sp>
+      <p:sp>
+        <p:nvSpPr>
+          <p:cNvPr id="13" name="TextBox 12"/>
+          <p:cNvSpPr txBox="1"/>
+          <p:nvPr/>
+        </p:nvSpPr>
+        <p:spPr>
+          <a:xfrm>
+            <a:off x="502920" y="5737360"/>
+            <a:ext cx="11155680" cy="560000"/>
+          </a:xfrm>
+          <a:prstGeom prst="rect">
+            <a:avLst/>
+          </a:prstGeom>
+          <a:noFill/>
+        </p:spPr>
+        <p:txBody>
+          <a:bodyPr wrap="square">
+            <a:spAutoFit/>
+          </a:bodyPr>
+          <a:lstStyle/>
+          <a:p>
+            <a:pPr>
+              <a:spcAft>
+                <a:spcPts val="600"/>
+              </a:spcAft>
+            </a:pPr>
+            <a:r>
+              <a:rPr sz="1200">
+                <a:solidFill>
+                  <a:srgbClr val="1A1F24"/>
+                </a:solidFill>
+                <a:latin typeface="Calibri"/>
+              </a:rPr>
+              <a:t>README.md documents setup instructions, full API specifications (requests, responses, status codes), database relationships, and the reasoning behind every query-optimization choice.</a:t>
             </a:r>
           </a:p>
         </p:txBody>

</xml_diff>

<commit_message>
Fix deck/code drift: test count and HMAC future-work bullet
Slide 4 still said 19 tests after slide 12 was corrected to 22.
Slide 14 listed webhook HMAC signature verification as future work,
but it's now implemented and pushed (see previous commit) — removed
the now-false bullet.
</commit_message>
<xml_diff>
--- a/LSA_Booking_Presentation.pptx
+++ b/LSA_Booking_Presentation.pptx
@@ -5958,22 +5958,6 @@
                 </a:solidFill>
                 <a:latin typeface="Calibri"/>
               </a:rPr>
-              <a:t>— Webhook signature verification (HMAC) to authenticate that events genuinely originate from the payment provider.</a:t>
-            </a:r>
-          </a:p>
-          <a:p>
-            <a:pPr>
-              <a:spcAft>
-                <a:spcPts val="2200"/>
-              </a:spcAft>
-            </a:pPr>
-            <a:r>
-              <a:rPr sz="1800">
-                <a:solidFill>
-                  <a:srgbClr val="1A1F24"/>
-                </a:solidFill>
-                <a:latin typeface="Calibri"/>
-              </a:rPr>
               <a:t>— Replace the httpbin.org placeholder verification URL with a real vendor integration when one is chosen.</a:t>
             </a:r>
           </a:p>
@@ -8476,7 +8460,7 @@
                 </a:solidFill>
                 <a:latin typeface="Calibri"/>
               </a:rPr>
-              <a:t>Django's unittest-based TestCase (19 tests)</a:t>
+              <a:t>Django's unittest-based TestCase (22 tests)</a:t>
             </a:r>
           </a:p>
         </p:txBody>

</xml_diff>